<commit_message>
Fix consistency issues across AI CoE artefact pack
</commit_message>
<xml_diff>
--- a/AI-CoE-How-To-Use.pptx
+++ b/AI-CoE-How-To-Use.pptx
@@ -1276,7 +1276,7 @@
           <a:p>
             <a:r>
               <a:rPr lang="en-US" dirty="0"/>
-              <a:t>60-second recap. Do not deep-dive — anyone in the room who needs the full pitch should read the pitch deck. Anchor on three things: 5+1 pillars, two streams, ATO funding.</a:t>
+              <a:t>60-second recap. Do not deep-dive — anyone in the room who needs the full pitch should read the pitch deck. Anchor on three things: 5+1 pillars, three streams, ATO funding.</a:t>
             </a:r>
           </a:p>
         </p:txBody>
@@ -11536,7 +11536,7 @@
                 <a:ea typeface="Segoe UI" pitchFamily="34" charset="-122"/>
                 <a:cs typeface="Segoe UI" pitchFamily="34" charset="-120"/>
               </a:rPr>
-              <a:t>External narrative · 18 slides</a:t>
+              <a:t>External narrative · 19 slides</a:t>
             </a:r>
             <a:endParaRPr lang="en-US" sz="1100" dirty="0"/>
           </a:p>

</xml_diff>